<commit_message>
chore(preview): secteur_Financial_Services_S&P_500 outputs regeneres
</commit_message>
<xml_diff>
--- a/preview/secteur_Financial_Services_S&P_500/secteur_Financial_Services_S&P_500.pptx
+++ b/preview/secteur_Financial_Services_S&P_500/secteur_Financial_Services_S&P_500.pptx
@@ -3470,7 +3470,7 @@
                   <a:srgbClr val="555555"/>
                 </a:solidFill>
               </a:rPr>
-              <a:t>13 avril 2026</a:t>
+              <a:t>14 avril 2026</a:t>
             </a:r>
           </a:p>
         </p:txBody>
@@ -4354,7 +4354,7 @@
                             <a:srgbClr val="1A1A1A"/>
                           </a:solidFill>
                         </a:rPr>
-                        <a:t>885.38</a:t>
+                        <a:t>890.79</a:t>
                       </a:r>
                     </a:p>
                   </a:txBody>
@@ -4434,7 +4434,7 @@
                             <a:srgbClr val="1A1A1A"/>
                           </a:solidFill>
                         </a:rPr>
-                        <a:t>+80.1 %</a:t>
+                        <a:t>+75.4 %</a:t>
                       </a:r>
                     </a:p>
                   </a:txBody>
@@ -4566,7 +4566,7 @@
                             <a:srgbClr val="1A1A1A"/>
                           </a:solidFill>
                         </a:rPr>
-                        <a:t>178.345</a:t>
+                        <a:t>181.14</a:t>
                       </a:r>
                     </a:p>
                   </a:txBody>
@@ -4654,7 +4654,7 @@
                             <a:srgbClr val="1A1A1A"/>
                           </a:solidFill>
                         </a:rPr>
-                        <a:t>+62.8 %</a:t>
+                        <a:t>+64.0 %</a:t>
                       </a:r>
                     </a:p>
                   </a:txBody>
@@ -4778,7 +4778,7 @@
                             <a:srgbClr val="1A1A1A"/>
                           </a:solidFill>
                         </a:rPr>
-                        <a:t>124.96</a:t>
+                        <a:t>126.28</a:t>
                       </a:r>
                     </a:p>
                   </a:txBody>
@@ -4858,7 +4858,7 @@
                             <a:srgbClr val="1A1A1A"/>
                           </a:solidFill>
                         </a:rPr>
-                        <a:t>+96.8 %</a:t>
+                        <a:t>+96.3 %</a:t>
                       </a:r>
                     </a:p>
                   </a:txBody>
@@ -4946,7 +4946,7 @@
                             <a:srgbClr val="1A1A1A"/>
                           </a:solidFill>
                         </a:rPr>
-                        <a:t>81/100</a:t>
+                        <a:t>80/100</a:t>
                       </a:r>
                     </a:p>
                   </a:txBody>
@@ -4990,7 +4990,7 @@
                             <a:srgbClr val="1A1A1A"/>
                           </a:solidFill>
                         </a:rPr>
-                        <a:t>52.805</a:t>
+                        <a:t>53.35</a:t>
                       </a:r>
                     </a:p>
                   </a:txBody>
@@ -5078,7 +5078,7 @@
                             <a:srgbClr val="1A1A1A"/>
                           </a:solidFill>
                         </a:rPr>
-                        <a:t>+43.3 %</a:t>
+                        <a:t>+40.4 %</a:t>
                       </a:r>
                     </a:p>
                   </a:txBody>
@@ -5202,7 +5202,7 @@
                             <a:srgbClr val="1A1A1A"/>
                           </a:solidFill>
                         </a:rPr>
-                        <a:t>85.695</a:t>
+                        <a:t>86.64</a:t>
                       </a:r>
                     </a:p>
                   </a:txBody>
@@ -5282,7 +5282,7 @@
                             <a:srgbClr val="1A1A1A"/>
                           </a:solidFill>
                         </a:rPr>
-                        <a:t>+35.3 %</a:t>
+                        <a:t>+34.2 %</a:t>
                       </a:r>
                     </a:p>
                   </a:txBody>
@@ -5414,7 +5414,7 @@
                             <a:srgbClr val="1A1A1A"/>
                           </a:solidFill>
                         </a:rPr>
-                        <a:t>318.11</a:t>
+                        <a:t>323.82</a:t>
                       </a:r>
                     </a:p>
                   </a:txBody>
@@ -5502,7 +5502,7 @@
                             <a:srgbClr val="1A1A1A"/>
                           </a:solidFill>
                         </a:rPr>
-                        <a:t>+22.8 %</a:t>
+                        <a:t>+25.6 %</a:t>
                       </a:r>
                     </a:p>
                   </a:txBody>
@@ -5626,7 +5626,7 @@
                             <a:srgbClr val="1A1A1A"/>
                           </a:solidFill>
                         </a:rPr>
-                        <a:t>1009.0</a:t>
+                        <a:t>1023.65</a:t>
                       </a:r>
                     </a:p>
                   </a:txBody>
@@ -5646,7 +5646,7 @@
                             <a:srgbClr val="1A1A1A"/>
                           </a:solidFill>
                         </a:rPr>
-                        <a:t>16.7x</a:t>
+                        <a:t>17.1x</a:t>
                       </a:r>
                     </a:p>
                   </a:txBody>
@@ -5706,7 +5706,7 @@
                             <a:srgbClr val="1A1A1A"/>
                           </a:solidFill>
                         </a:rPr>
-                        <a:t>+12.3 %</a:t>
+                        <a:t>+15.2 %</a:t>
                       </a:r>
                     </a:p>
                   </a:txBody>
@@ -5838,7 +5838,7 @@
                             <a:srgbClr val="1A1A1A"/>
                           </a:solidFill>
                         </a:rPr>
-                        <a:t>310.54</a:t>
+                        <a:t>313.68</a:t>
                       </a:r>
                     </a:p>
                   </a:txBody>
@@ -5926,7 +5926,7 @@
                             <a:srgbClr val="1A1A1A"/>
                           </a:solidFill>
                         </a:rPr>
-                        <a:t>+32.0 %</a:t>
+                        <a:t>+34.6 %</a:t>
                       </a:r>
                     </a:p>
                   </a:txBody>
@@ -6859,7 +6859,7 @@
                   <a:srgbClr val="555555"/>
                 </a:solidFill>
               </a:rPr>
-              <a:t>Médiane sectorielle : 16.7x. Les barres vertes sous cette ligne sont les candidats privilegies a analyser via Analyse Société individuelle (DCF, WACC, scénarios).</a:t>
+              <a:t>Médiane sectorielle : 17.1x. Les barres vertes sous cette ligne sont les candidats privilegies a analyser via Analyse Société individuelle (DCF, WACC, scénarios).</a:t>
             </a:r>
           </a:p>
         </p:txBody>
@@ -7800,7 +7800,7 @@
                             <a:srgbClr val="A82020"/>
                           </a:solidFill>
                         </a:rPr>
-                        <a:t>24</a:t>
+                        <a:t>23</a:t>
                       </a:r>
                     </a:p>
                   </a:txBody>
@@ -8224,7 +8224,7 @@
                             <a:srgbClr val="1A1A1A"/>
                           </a:solidFill>
                         </a:rPr>
-                        <a:t>81/100</a:t>
+                        <a:t>80/100</a:t>
                       </a:r>
                     </a:p>
                   </a:txBody>
@@ -8820,7 +8820,7 @@
                             <a:srgbClr val="A82020"/>
                           </a:solidFill>
                         </a:rPr>
-                        <a:t>13</a:t>
+                        <a:t>14</a:t>
                       </a:r>
                     </a:p>
                   </a:txBody>
@@ -8990,7 +8990,7 @@
                             <a:srgbClr val="A82020"/>
                           </a:solidFill>
                         </a:rPr>
-                        <a:t>16</a:t>
+                        <a:t>17</a:t>
                       </a:r>
                     </a:p>
                   </a:txBody>
@@ -9174,7 +9174,7 @@
                   <a:srgbClr val="555555"/>
                 </a:solidFill>
               </a:rPr>
-              <a:t>The Goldman Sachs Group,  présente le profil le plus équilibre du secteur (90/100) avec des scores Value=16, Growth=25, Quality=25, Momentum=24. La dispersion des scores entre les 8 sociétés Reflète des profils hétérogènes — une allocation selective privilegiant les leaders qualitatifs est recommandee dans la configuration sectorielle actuelle.</a:t>
+              <a:t>The Goldman Sachs Group,  présente le profil le plus équilibre du secteur (90/100) avec des scores Value=16, Growth=25, Quality=25, Momentum=23. La dispersion des scores entre les 8 sociétés Reflète des profils hétérogènes — une allocation selective privilegiant les leaders qualitatifs est recommandee dans la configuration sectorielle actuelle.</a:t>
             </a:r>
           </a:p>
         </p:txBody>
@@ -10313,7 +10313,7 @@
                   <a:srgbClr val="FFFFFF"/>
                 </a:solidFill>
               </a:rPr>
-              <a:t>Cible : 1062</a:t>
+              <a:t>Cible : 1069</a:t>
             </a:r>
           </a:p>
         </p:txBody>
@@ -10868,7 +10868,7 @@
                   <a:srgbClr val="555555"/>
                 </a:solidFill>
               </a:rPr>
-              <a:t>Les anticipations de baisses des taux de la Fed à partir de mi-2024 devraient soutenir la demande de crédit et les volumes de transactions sur les marchés de</a:t>
+              <a:t>Maintien des taux BCE a 3 % — soutien structurel aux NIM bancaires et a la rentabilité des depots.</a:t>
             </a:r>
           </a:p>
         </p:txBody>
@@ -11022,7 +11022,7 @@
                   <a:srgbClr val="555555"/>
                 </a:solidFill>
               </a:rPr>
-              <a:t>Un durcissement inattendu des conditions de crédit pourrait peser sur les marges des banques commerciales comme C, notamment dans les segments des</a:t>
+              <a:t>Hausse des NPL dans l'immobilier commercial et le crédit PME si récession confirmee.</a:t>
             </a:r>
           </a:p>
         </p:txBody>
@@ -11330,7 +11330,7 @@
                   <a:srgbClr val="FFFFFF"/>
                 </a:solidFill>
               </a:rPr>
-              <a:t>Cible : 214</a:t>
+              <a:t>Cible : 217</a:t>
             </a:r>
           </a:p>
         </p:txBody>
@@ -11885,7 +11885,7 @@
                   <a:srgbClr val="555555"/>
                 </a:solidFill>
               </a:rPr>
-              <a:t>L'assouplissement progressif des règles de Bâle IV en Europe et aux États-Unis pourrait réduire les coûts en capital pour les banques d'investissement comme GS</a:t>
+              <a:t>Fusions-acquisitions dans la banque retail — prime de contrôle sur les cibles sous-valorisees.</a:t>
             </a:r>
           </a:p>
         </p:txBody>
@@ -12039,7 +12039,7 @@
                   <a:srgbClr val="555555"/>
                 </a:solidFill>
               </a:rPr>
-              <a:t>Les tensions commerciales persistantes entre les États-Unis et la Chine menacent les revenus des banques d'investissement exposées aux flux</a:t>
+              <a:t>Pivot accommodant — compression des NIM de 15-25 bps par tranche de 25 bps de baisse.</a:t>
             </a:r>
           </a:p>
         </p:txBody>
@@ -12347,7 +12347,7 @@
                   <a:srgbClr val="FFFFFF"/>
                 </a:solidFill>
               </a:rPr>
-              <a:t>Cible : 150</a:t>
+              <a:t>Cible : 152</a:t>
             </a:r>
           </a:p>
         </p:txBody>
@@ -12492,7 +12492,7 @@
                   <a:srgbClr val="555555"/>
                 </a:solidFill>
               </a:rPr>
-              <a:t>EV/EBITDA</a:t>
+              <a:t>P/E</a:t>
             </a:r>
           </a:p>
         </p:txBody>
@@ -12526,7 +12526,7 @@
                   <a:srgbClr val="1B3A6B"/>
                 </a:solidFill>
               </a:rPr>
-              <a:t>—</a:t>
+              <a:t>18.0x</a:t>
             </a:r>
           </a:p>
         </p:txBody>
@@ -12603,7 +12603,7 @@
                   <a:srgbClr val="555555"/>
                 </a:solidFill>
               </a:rPr>
-              <a:t>Marge EBITDA</a:t>
+              <a:t>P/B</a:t>
             </a:r>
           </a:p>
         </p:txBody>
@@ -12637,7 +12637,7 @@
                   <a:srgbClr val="1B3A6B"/>
                 </a:solidFill>
               </a:rPr>
-              <a:t>0.0 %</a:t>
+              <a:t>1.1x</a:t>
             </a:r>
           </a:p>
         </p:txBody>
@@ -12714,7 +12714,7 @@
                   <a:srgbClr val="555555"/>
                 </a:solidFill>
               </a:rPr>
-              <a:t>Altman Z</a:t>
+              <a:t>ROE</a:t>
             </a:r>
           </a:p>
         </p:txBody>
@@ -12748,7 +12748,7 @@
                   <a:srgbClr val="1B3A6B"/>
                 </a:solidFill>
               </a:rPr>
-              <a:t>—</a:t>
+              <a:t>6.8 %</a:t>
             </a:r>
           </a:p>
         </p:txBody>
@@ -12902,7 +12902,7 @@
                   <a:srgbClr val="555555"/>
                 </a:solidFill>
               </a:rPr>
-              <a:t>L'adoption accélérée de l'IA et des solutions cloud dans les services financiers optimise les coûts opérationnels et améliore l'efficacité des plateformes de</a:t>
+              <a:t>Plateformes wealth management numeriques — réduction Coûts et captation millennials investisseurs.</a:t>
             </a:r>
           </a:p>
         </p:txBody>
@@ -13056,7 +13056,7 @@
                   <a:srgbClr val="555555"/>
                 </a:solidFill>
               </a:rPr>
-              <a:t>L'augmentation des cyberattaques ciblant les infrastructures financières pourrait entraîner des coûts de conformité et de réparation significatifs.</a:t>
+              <a:t>Exigences CET1 plus élevées — pression sur le ROE et les politiques de retour de capital.</a:t>
             </a:r>
           </a:p>
         </p:txBody>
@@ -13647,7 +13647,7 @@
                   <a:srgbClr val="555555"/>
                 </a:solidFill>
               </a:rPr>
-              <a:t>EV/EBITDA par société vs médiane sectorielle (16.7x)  ·  Vert = sous médiane  ·  Rouge = prime</a:t>
+              <a:t>EV/EBITDA par société vs médiane sectorielle (17.1x)  ·  Vert = sous médiane  ·  Rouge = prime</a:t>
             </a:r>
           </a:p>
         </p:txBody>
@@ -13825,7 +13825,7 @@
                   <a:srgbClr val="555555"/>
                 </a:solidFill>
               </a:rPr>
-              <a:t>La distribution est homogene — 0 acteur(s) se detachent nettement du reste du secteur, creant une prime de valorisation significative vs la médiane de 16.7x.
+              <a:t>La distribution est homogene — 0 acteur(s) se detachent nettement du reste du secteur, creant une prime de valorisation significative vs la médiane de 17.1x.
 0 société(s) se traitent sous la médiane — potentiellement les meilleures asymétries risque/rendement sous reserve de catalyseurs fondamentaux.
 La dispersion des multiples est caractéristique d'un secteur Services Financiers en phase de différentiation — les investisseurs selectifs peuvent exploiter cet Écart.</a:t>
             </a:r>
@@ -14779,7 +14779,7 @@
                             <a:srgbClr val="1A1A1A"/>
                           </a:solidFill>
                         </a:rPr>
-                        <a:t>885.38</a:t>
+                        <a:t>890.79</a:t>
                       </a:r>
                     </a:p>
                   </a:txBody>
@@ -14799,7 +14799,7 @@
                             <a:srgbClr val="1A1A1A"/>
                           </a:solidFill>
                         </a:rPr>
-                        <a:t>1018.2</a:t>
+                        <a:t>1024.4</a:t>
                       </a:r>
                     </a:p>
                   </a:txBody>
@@ -14819,7 +14819,7 @@
                             <a:srgbClr val="1A1A1A"/>
                           </a:solidFill>
                         </a:rPr>
-                        <a:t>&lt; 841.1</a:t>
+                        <a:t>&lt; 846.3</a:t>
                       </a:r>
                     </a:p>
                   </a:txBody>
@@ -14925,7 +14925,7 @@
                             <a:srgbClr val="1A1A1A"/>
                           </a:solidFill>
                         </a:rPr>
-                        <a:t>178.345</a:t>
+                        <a:t>181.14</a:t>
                       </a:r>
                     </a:p>
                   </a:txBody>
@@ -14947,7 +14947,7 @@
                             <a:srgbClr val="1A1A1A"/>
                           </a:solidFill>
                         </a:rPr>
-                        <a:t>205.1</a:t>
+                        <a:t>208.3</a:t>
                       </a:r>
                     </a:p>
                   </a:txBody>
@@ -14969,7 +14969,7 @@
                             <a:srgbClr val="1A1A1A"/>
                           </a:solidFill>
                         </a:rPr>
-                        <a:t>&lt; 169.4</a:t>
+                        <a:t>&lt; 172.1</a:t>
                       </a:r>
                     </a:p>
                   </a:txBody>
@@ -15077,7 +15077,7 @@
                             <a:srgbClr val="1A1A1A"/>
                           </a:solidFill>
                         </a:rPr>
-                        <a:t>124.96</a:t>
+                        <a:t>126.28</a:t>
                       </a:r>
                     </a:p>
                   </a:txBody>
@@ -15097,7 +15097,7 @@
                             <a:srgbClr val="1A1A1A"/>
                           </a:solidFill>
                         </a:rPr>
-                        <a:t>143.7</a:t>
+                        <a:t>145.2</a:t>
                       </a:r>
                     </a:p>
                   </a:txBody>
@@ -15117,7 +15117,7 @@
                             <a:srgbClr val="1A1A1A"/>
                           </a:solidFill>
                         </a:rPr>
-                        <a:t>&lt; 118.7</a:t>
+                        <a:t>&lt; 120.0</a:t>
                       </a:r>
                     </a:p>
                   </a:txBody>
@@ -15223,7 +15223,7 @@
                             <a:srgbClr val="1A1A1A"/>
                           </a:solidFill>
                         </a:rPr>
-                        <a:t>52.805</a:t>
+                        <a:t>53.35</a:t>
                       </a:r>
                     </a:p>
                   </a:txBody>
@@ -15245,7 +15245,7 @@
                             <a:srgbClr val="1A1A1A"/>
                           </a:solidFill>
                         </a:rPr>
-                        <a:t>60.7</a:t>
+                        <a:t>61.4</a:t>
                       </a:r>
                     </a:p>
                   </a:txBody>
@@ -15267,7 +15267,7 @@
                             <a:srgbClr val="1A1A1A"/>
                           </a:solidFill>
                         </a:rPr>
-                        <a:t>&lt; 50.2</a:t>
+                        <a:t>&lt; 50.7</a:t>
                       </a:r>
                     </a:p>
                   </a:txBody>
@@ -15375,7 +15375,7 @@
                             <a:srgbClr val="1A1A1A"/>
                           </a:solidFill>
                         </a:rPr>
-                        <a:t>85.695</a:t>
+                        <a:t>86.64</a:t>
                       </a:r>
                     </a:p>
                   </a:txBody>
@@ -15395,7 +15395,7 @@
                             <a:srgbClr val="1A1A1A"/>
                           </a:solidFill>
                         </a:rPr>
-                        <a:t>98.5</a:t>
+                        <a:t>99.6</a:t>
                       </a:r>
                     </a:p>
                   </a:txBody>
@@ -15415,7 +15415,7 @@
                             <a:srgbClr val="1A1A1A"/>
                           </a:solidFill>
                         </a:rPr>
-                        <a:t>&lt; 81.4</a:t>
+                        <a:t>&lt; 82.3</a:t>
                       </a:r>
                     </a:p>
                   </a:txBody>
@@ -15521,7 +15521,7 @@
                             <a:srgbClr val="1A1A1A"/>
                           </a:solidFill>
                         </a:rPr>
-                        <a:t>318.11</a:t>
+                        <a:t>323.82</a:t>
                       </a:r>
                     </a:p>
                   </a:txBody>
@@ -15543,7 +15543,7 @@
                             <a:srgbClr val="1A1A1A"/>
                           </a:solidFill>
                         </a:rPr>
-                        <a:t>365.8</a:t>
+                        <a:t>372.4</a:t>
                       </a:r>
                     </a:p>
                   </a:txBody>
@@ -15565,7 +15565,7 @@
                             <a:srgbClr val="1A1A1A"/>
                           </a:solidFill>
                         </a:rPr>
-                        <a:t>&lt; 302.2</a:t>
+                        <a:t>&lt; 307.6</a:t>
                       </a:r>
                     </a:p>
                   </a:txBody>
@@ -15673,7 +15673,7 @@
                             <a:srgbClr val="1A1A1A"/>
                           </a:solidFill>
                         </a:rPr>
-                        <a:t>1009.0</a:t>
+                        <a:t>1023.65</a:t>
                       </a:r>
                     </a:p>
                   </a:txBody>
@@ -15693,7 +15693,7 @@
                             <a:srgbClr val="1A1A1A"/>
                           </a:solidFill>
                         </a:rPr>
-                        <a:t>1160.3</a:t>
+                        <a:t>1177.2</a:t>
                       </a:r>
                     </a:p>
                   </a:txBody>
@@ -15713,7 +15713,7 @@
                             <a:srgbClr val="1A1A1A"/>
                           </a:solidFill>
                         </a:rPr>
-                        <a:t>&lt; 958.5</a:t>
+                        <a:t>&lt; 972.5</a:t>
                       </a:r>
                     </a:p>
                   </a:txBody>
@@ -15819,7 +15819,7 @@
                             <a:srgbClr val="1A1A1A"/>
                           </a:solidFill>
                         </a:rPr>
-                        <a:t>310.54</a:t>
+                        <a:t>313.68</a:t>
                       </a:r>
                     </a:p>
                   </a:txBody>
@@ -15841,7 +15841,7 @@
                             <a:srgbClr val="1A1A1A"/>
                           </a:solidFill>
                         </a:rPr>
-                        <a:t>357.1</a:t>
+                        <a:t>360.7</a:t>
                       </a:r>
                     </a:p>
                   </a:txBody>
@@ -15863,7 +15863,7 @@
                             <a:srgbClr val="1A1A1A"/>
                           </a:solidFill>
                         </a:rPr>
-                        <a:t>&lt; 295.0</a:t>
+                        <a:t>&lt; 298.0</a:t>
                       </a:r>
                     </a:p>
                   </a:txBody>
@@ -17022,7 +17022,7 @@
                   <a:srgbClr val="FFFFFF"/>
                 </a:solidFill>
               </a:rPr>
-              <a:t>Crédit</a:t>
+              <a:t>Dégradâtion Crédit</a:t>
             </a:r>
           </a:p>
         </p:txBody>
@@ -17056,7 +17056,7 @@
                   <a:srgbClr val="555555"/>
                 </a:solidFill>
               </a:rPr>
-              <a:t>Un durcissement inattendu des conditions de crédit pourrait peser sur les marges des banques commerciales comme C, notamment dans les segments des PME et des particuliers.</a:t>
+              <a:t>Hausse des NPL dans l'immobilier commercial et le crédit PME si récession confirmee.</a:t>
             </a:r>
           </a:p>
         </p:txBody>
@@ -17176,7 +17176,7 @@
                   <a:srgbClr val="FFFFFF"/>
                 </a:solidFill>
               </a:rPr>
-              <a:t>Géopolitique</a:t>
+              <a:t>Baisse Taux BCE</a:t>
             </a:r>
           </a:p>
         </p:txBody>
@@ -17210,7 +17210,7 @@
                   <a:srgbClr val="555555"/>
                 </a:solidFill>
               </a:rPr>
-              <a:t>Les tensions commerciales persistantes entre les États-Unis et la Chine menacent les revenus des banques d'investissement exposées aux flux transpacifiques.</a:t>
+              <a:t>Pivot accommodant — compression des NIM de 15-25 bps par tranche de 25 bps de baisse.</a:t>
             </a:r>
           </a:p>
         </p:txBody>
@@ -17330,7 +17330,7 @@
                   <a:srgbClr val="FFFFFF"/>
                 </a:solidFill>
               </a:rPr>
-              <a:t>Cyber</a:t>
+              <a:t>Régulation Bale IV</a:t>
             </a:r>
           </a:p>
         </p:txBody>
@@ -17364,7 +17364,7 @@
                   <a:srgbClr val="555555"/>
                 </a:solidFill>
               </a:rPr>
-              <a:t>L'augmentation des cyberattaques ciblant les infrastructures financières pourrait entraîner des coûts de conformité et de réparation significatifs.</a:t>
+              <a:t>Exigences CET1 plus élevées — pression sur le ROE et les politiques de retour de capital.</a:t>
             </a:r>
           </a:p>
         </p:txBody>
@@ -18095,7 +18095,7 @@
                   <a:srgbClr val="1B3A6B"/>
                 </a:solidFill>
               </a:rPr>
-              <a:t>4.5%</a:t>
+              <a:t>4.4%</a:t>
             </a:r>
           </a:p>
         </p:txBody>
@@ -18283,7 +18283,7 @@
                   <a:srgbClr val="1B3A6B"/>
                 </a:solidFill>
               </a:rPr>
-              <a:t>79/100</a:t>
+              <a:t>78/100</a:t>
             </a:r>
           </a:p>
         </p:txBody>
@@ -19617,7 +19617,7 @@
                   <a:srgbClr val="555555"/>
                 </a:solidFill>
               </a:rPr>
-              <a:t>+ Politiques monétaires — Les anticipations de baisses des taux de la Fed à partir de mi-2024 devraient soutenir la</a:t>
+              <a:t>+ Taux Directeurs Élevés — Maintien des taux BCE a 3 % — soutien structurel aux NIM bancaires et a la rentabilité</a:t>
             </a:r>
           </a:p>
         </p:txBody>
@@ -19737,7 +19737,7 @@
                   <a:srgbClr val="555555"/>
                 </a:solidFill>
               </a:rPr>
-              <a:t>- Crédit — Un durcissement inattendu des conditions de crédit pourrait peser sur les marges des</a:t>
+              <a:t>- Dégradâtion Crédit — Hausse des NPL dans l'immobilier commercial et le crédit PME si récession confirmee.</a:t>
             </a:r>
           </a:p>
         </p:txBody>
@@ -20636,7 +20636,7 @@
                   <a:srgbClr val="1B3A6B"/>
                 </a:solidFill>
               </a:rPr>
-              <a:t>EV/EBITDA med. : 16.7x  ·  Croissance med. : +8.9 %  ·  Marge EBITDA med. : 0.0 %  ·  Score moyen : 80/100</a:t>
+              <a:t>EV/EBITDA med. : 17.1x  ·  Croissance med. : +8.9 %  ·  Marge EBITDA med. : 0.0 %  ·  Score moyen : 80/100</a:t>
             </a:r>
           </a:p>
         </p:txBody>
@@ -20833,7 +20833,7 @@
                   <a:srgbClr val="1B3A6B"/>
                 </a:solidFill>
               </a:rPr>
-              <a:t>Politiques monétaires</a:t>
+              <a:t>Taux Directeurs Élevés</a:t>
             </a:r>
           </a:p>
         </p:txBody>
@@ -20867,7 +20867,7 @@
                   <a:srgbClr val="555555"/>
                 </a:solidFill>
               </a:rPr>
-              <a:t>Les anticipations de baisses des taux de la Fed à partir de mi-2024 devraient soutenir la demande de crédit et les volumes de transactions sur les marchés de capitaux.</a:t>
+              <a:t>Maintien des taux BCE a 3 % — soutien structurel aux NIM bancaires et a la rentabilité des depots.</a:t>
             </a:r>
           </a:p>
         </p:txBody>
@@ -20987,7 +20987,7 @@
                   <a:srgbClr val="1B3A6B"/>
                 </a:solidFill>
               </a:rPr>
-              <a:t>Réglementation</a:t>
+              <a:t>Consolidation Sectorielle</a:t>
             </a:r>
           </a:p>
         </p:txBody>
@@ -21021,7 +21021,7 @@
                   <a:srgbClr val="555555"/>
                 </a:solidFill>
               </a:rPr>
-              <a:t>L'assouplissement progressif des règles de Bâle IV en Europe et aux États-Unis pourrait réduire les coûts en capital pour les banques d'investissement comme GS et MS.</a:t>
+              <a:t>Fusions-acquisitions dans la banque retail — prime de contrôle sur les cibles sous-valorisees.</a:t>
             </a:r>
           </a:p>
         </p:txBody>
@@ -21141,7 +21141,7 @@
                   <a:srgbClr val="1B3A6B"/>
                 </a:solidFill>
               </a:rPr>
-              <a:t>Technologie</a:t>
+              <a:t>Digitalisation Services</a:t>
             </a:r>
           </a:p>
         </p:txBody>
@@ -21175,7 +21175,7 @@
                   <a:srgbClr val="555555"/>
                 </a:solidFill>
               </a:rPr>
-              <a:t>L'adoption accélérée de l'IA et des solutions cloud dans les services financiers optimise les coûts opérationnels et améliore l'efficacité des plateformes de trading.</a:t>
+              <a:t>Plateformes wealth management numeriques — réduction Coûts et captation millennials investisseurs.</a:t>
             </a:r>
           </a:p>
         </p:txBody>
@@ -21372,7 +21372,7 @@
                   <a:srgbClr val="A82020"/>
                 </a:solidFill>
               </a:rPr>
-              <a:t>Crédit</a:t>
+              <a:t>Dégradâtion Crédit</a:t>
             </a:r>
           </a:p>
         </p:txBody>
@@ -21406,7 +21406,7 @@
                   <a:srgbClr val="555555"/>
                 </a:solidFill>
               </a:rPr>
-              <a:t>Un durcissement inattendu des conditions de crédit pourrait peser sur les marges des banques commerciales comme C, notamment dans les segments des PME et des particuliers.</a:t>
+              <a:t>Hausse des NPL dans l'immobilier commercial et le crédit PME si récession confirmee.</a:t>
             </a:r>
           </a:p>
         </p:txBody>
@@ -21526,7 +21526,7 @@
                   <a:srgbClr val="A82020"/>
                 </a:solidFill>
               </a:rPr>
-              <a:t>Géopolitique</a:t>
+              <a:t>Baisse Taux BCE</a:t>
             </a:r>
           </a:p>
         </p:txBody>
@@ -21560,7 +21560,7 @@
                   <a:srgbClr val="555555"/>
                 </a:solidFill>
               </a:rPr>
-              <a:t>Les tensions commerciales persistantes entre les États-Unis et la Chine menacent les revenus des banques d'investissement exposées aux flux transpacifiques.</a:t>
+              <a:t>Pivot accommodant — compression des NIM de 15-25 bps par tranche de 25 bps de baisse.</a:t>
             </a:r>
           </a:p>
         </p:txBody>
@@ -21680,7 +21680,7 @@
                   <a:srgbClr val="A82020"/>
                 </a:solidFill>
               </a:rPr>
-              <a:t>Cyber</a:t>
+              <a:t>Régulation Bale IV</a:t>
             </a:r>
           </a:p>
         </p:txBody>
@@ -21714,7 +21714,7 @@
                   <a:srgbClr val="555555"/>
                 </a:solidFill>
               </a:rPr>
-              <a:t>L'augmentation des cyberattaques ciblant les infrastructures financières pourrait entraîner des coûts de conformité et de réparation significatifs.</a:t>
+              <a:t>Exigences CET1 plus élevées — pression sur le ROE et les politiques de retour de capital.</a:t>
             </a:r>
           </a:p>
         </p:txBody>
@@ -21834,7 +21834,7 @@
                   <a:srgbClr val="1B3A6B"/>
                 </a:solidFill>
               </a:rPr>
-              <a:t>16.7x</a:t>
+              <a:t>17.1x</a:t>
             </a:r>
           </a:p>
         </p:txBody>
@@ -22398,7 +22398,7 @@
                   <a:srgbClr val="1B3A6B"/>
                 </a:solidFill>
               </a:rPr>
-              <a:t>+39.3 %</a:t>
+              <a:t>+37.5 %</a:t>
             </a:r>
           </a:p>
         </p:txBody>
@@ -23269,7 +23269,7 @@
                   <a:srgbClr val="1B3A6B"/>
                 </a:solidFill>
               </a:rPr>
-              <a:t>C  +97%  sur 52 semaines</a:t>
+              <a:t>C  +96%  sur 52 semaines</a:t>
             </a:r>
           </a:p>
         </p:txBody>
@@ -23337,7 +23337,7 @@
                   <a:srgbClr val="A82020"/>
                 </a:solidFill>
               </a:rPr>
-              <a:t>BLK  +12%  sur 52 semaines</a:t>
+              <a:t>BLK  +15%  sur 52 semaines</a:t>
             </a:r>
           </a:p>
         </p:txBody>
@@ -23405,7 +23405,7 @@
                   <a:srgbClr val="555555"/>
                 </a:solidFill>
               </a:rPr>
-              <a:t>Écart 84 pts — 8 valeur(s) positives vs 0 négatives.</a:t>
+              <a:t>Écart 81 pts — 8 valeur(s) positives vs 0 négatives.</a:t>
             </a:r>
           </a:p>
         </p:txBody>
@@ -23679,7 +23679,7 @@
                   <a:srgbClr val="FFFFFF"/>
                 </a:solidFill>
               </a:rPr>
-              <a:t>Sources &amp; Méthodologie</a:t>
+              <a:t>Avertissement &amp; Méthodologie</a:t>
             </a:r>
           </a:p>
         </p:txBody>
@@ -27273,7 +27273,7 @@
                   <a:srgbClr val="555555"/>
                 </a:solidFill>
               </a:rPr>
-              <a:t>Services Financiers  ·  Caractéristiques structurelles &amp; metriques_dict de référence</a:t>
+              <a:t>Services Financiers  ·  Caractéristiques structurelles &amp; métriques de référence</a:t>
             </a:r>
           </a:p>
         </p:txBody>
@@ -27287,7 +27287,7 @@
         <p:spPr>
           <a:xfrm>
             <a:off x="324000" y="900000"/>
-            <a:ext cx="4932000" cy="3600000"/>
+            <a:ext cx="4932000" cy="1260000"/>
           </a:xfrm>
           <a:prstGeom prst="rect">
             <a:avLst/>
@@ -27330,7 +27330,7 @@
         <p:spPr>
           <a:xfrm>
             <a:off x="324000" y="900000"/>
-            <a:ext cx="36000" cy="3600000"/>
+            <a:ext cx="36000" cy="1260000"/>
           </a:xfrm>
           <a:prstGeom prst="rect">
             <a:avLst/>
@@ -27366,48 +27366,14 @@
       </p:sp>
       <p:sp>
         <p:nvSpPr>
-          <p:cNvPr id="17" name="TextBox 16"/>
-          <p:cNvSpPr txBox="1"/>
-          <p:nvPr/>
-        </p:nvSpPr>
-        <p:spPr>
-          <a:xfrm>
-            <a:off x="468000" y="972000"/>
-            <a:ext cx="4716000" cy="1080000"/>
-          </a:xfrm>
-          <a:prstGeom prst="rect">
-            <a:avLst/>
-          </a:prstGeom>
-          <a:noFill/>
-        </p:spPr>
-        <p:txBody>
-          <a:bodyPr wrap="square">
-            <a:spAutoFit/>
-          </a:bodyPr>
-          <a:lstStyle/>
-          <a:p>
-            <a:pPr algn="l"/>
-            <a:r>
-              <a:rPr sz="900" b="0" i="0">
-                <a:solidFill>
-                  <a:srgbClr val="555555"/>
-                </a:solidFill>
-              </a:rPr>
-              <a:t>Le secteur des Financial Services affiche une valorisation attractive avec un multiple EV/EBITDA médian de 16.7x, proche de sa moyenne historique, malgré une marge EBITDA stagnante à 0.0% reflétant des pressions concurrentielles sur les taux et les coûts de conformité. La croissance des revenus à +8.9% et un momentum 52 semaines de +39.3% indiquent une dynamique de reprise post-réglementaire et une exposition favorable aux marchés actions et aux fusions-acquisitions.</a:t>
-            </a:r>
-          </a:p>
-        </p:txBody>
-      </p:sp>
-      <p:sp>
-        <p:nvSpPr>
-          <p:cNvPr id="18" name="Rectangle 17"/>
+          <p:cNvPr id="17" name="Rectangle 16"/>
           <p:cNvSpPr/>
           <p:nvPr/>
         </p:nvSpPr>
         <p:spPr>
           <a:xfrm>
-            <a:off x="324000" y="2160000"/>
-            <a:ext cx="4932000" cy="162000"/>
+            <a:off x="324000" y="900000"/>
+            <a:ext cx="4932000" cy="198000"/>
           </a:xfrm>
           <a:prstGeom prst="rect">
             <a:avLst/>
@@ -27443,14 +27409,14 @@
       </p:sp>
       <p:sp>
         <p:nvSpPr>
-          <p:cNvPr id="19" name="TextBox 18"/>
+          <p:cNvPr id="18" name="TextBox 17"/>
           <p:cNvSpPr txBox="1"/>
           <p:nvPr/>
         </p:nvSpPr>
         <p:spPr>
           <a:xfrm>
-            <a:off x="324000" y="2178000"/>
-            <a:ext cx="4932000" cy="144000"/>
+            <a:off x="396000" y="928800"/>
+            <a:ext cx="4788000" cy="162000"/>
           </a:xfrm>
           <a:prstGeom prst="rect">
             <a:avLst/>
@@ -27463,14 +27429,48 @@
           </a:bodyPr>
           <a:lstStyle/>
           <a:p>
-            <a:pPr algn="ctr"/>
-            <a:r>
-              <a:rPr sz="800" b="1" i="0">
+            <a:pPr algn="l"/>
+            <a:r>
+              <a:rPr sz="900" b="1" i="0">
                 <a:solidFill>
                   <a:srgbClr val="FFFFFF"/>
                 </a:solidFill>
               </a:rPr>
-              <a:t>CATALYSEURS CLES</a:t>
+              <a:t>PANORAMA SECTORIEL</a:t>
+            </a:r>
+          </a:p>
+        </p:txBody>
+      </p:sp>
+      <p:sp>
+        <p:nvSpPr>
+          <p:cNvPr id="19" name="TextBox 18"/>
+          <p:cNvSpPr txBox="1"/>
+          <p:nvPr/>
+        </p:nvSpPr>
+        <p:spPr>
+          <a:xfrm>
+            <a:off x="468000" y="1152000"/>
+            <a:ext cx="4716000" cy="936000"/>
+          </a:xfrm>
+          <a:prstGeom prst="rect">
+            <a:avLst/>
+          </a:prstGeom>
+          <a:noFill/>
+        </p:spPr>
+        <p:txBody>
+          <a:bodyPr wrap="square">
+            <a:spAutoFit/>
+          </a:bodyPr>
+          <a:lstStyle/>
+          <a:p>
+            <a:pPr algn="l"/>
+            <a:r>
+              <a:rPr sz="1000" b="0" i="0">
+                <a:solidFill>
+                  <a:srgbClr val="555555"/>
+                </a:solidFill>
+              </a:rPr>
+              <a:t>Le secteur Financier couvre les banques, assureurs, sociétés de gestion d'actifs et fintech. L'environnement de taux élevés a restaure la rentabilité des marges d'intérêt, mais l'exposition au crédit immobilier et aux PME reste un facteur de risque dans un contexte macro degrade.</a:t>
             </a:r>
           </a:p>
         </p:txBody>
@@ -27483,14 +27483,14 @@
         </p:nvSpPr>
         <p:spPr>
           <a:xfrm>
-            <a:off x="360000" y="2358000"/>
-            <a:ext cx="28800" cy="486000"/>
+            <a:off x="324000" y="2268000"/>
+            <a:ext cx="4932000" cy="2394000"/>
           </a:xfrm>
           <a:prstGeom prst="rect">
             <a:avLst/>
           </a:prstGeom>
           <a:solidFill>
-            <a:srgbClr val="1A7A4A"/>
+            <a:srgbClr val="F5F7FA"/>
           </a:solidFill>
           <a:ln>
             <a:noFill/>
@@ -27520,88 +27520,20 @@
       </p:sp>
       <p:sp>
         <p:nvSpPr>
-          <p:cNvPr id="21" name="TextBox 20"/>
-          <p:cNvSpPr txBox="1"/>
-          <p:nvPr/>
-        </p:nvSpPr>
-        <p:spPr>
-          <a:xfrm>
-            <a:off x="468000" y="2358000"/>
-            <a:ext cx="4716000" cy="162000"/>
-          </a:xfrm>
-          <a:prstGeom prst="rect">
-            <a:avLst/>
-          </a:prstGeom>
-          <a:noFill/>
-        </p:spPr>
-        <p:txBody>
-          <a:bodyPr wrap="square">
-            <a:spAutoFit/>
-          </a:bodyPr>
-          <a:lstStyle/>
-          <a:p>
-            <a:pPr algn="l"/>
-            <a:r>
-              <a:rPr sz="850" b="1" i="0">
-                <a:solidFill>
-                  <a:srgbClr val="1B3A6B"/>
-                </a:solidFill>
-              </a:rPr>
-              <a:t>Politiques monétaires</a:t>
-            </a:r>
-          </a:p>
-        </p:txBody>
-      </p:sp>
-      <p:sp>
-        <p:nvSpPr>
-          <p:cNvPr id="22" name="TextBox 21"/>
-          <p:cNvSpPr txBox="1"/>
-          <p:nvPr/>
-        </p:nvSpPr>
-        <p:spPr>
-          <a:xfrm>
-            <a:off x="468000" y="2520000"/>
-            <a:ext cx="4716000" cy="378000"/>
-          </a:xfrm>
-          <a:prstGeom prst="rect">
-            <a:avLst/>
-          </a:prstGeom>
-          <a:noFill/>
-        </p:spPr>
-        <p:txBody>
-          <a:bodyPr wrap="square">
-            <a:spAutoFit/>
-          </a:bodyPr>
-          <a:lstStyle/>
-          <a:p>
-            <a:pPr algn="l"/>
-            <a:r>
-              <a:rPr sz="800" b="0" i="0">
-                <a:solidFill>
-                  <a:srgbClr val="555555"/>
-                </a:solidFill>
-              </a:rPr>
-              <a:t>Les anticipations de baisses des taux de la Fed à partir de mi-2024 devraient soutenir la demande de crédit et les volumes de transactions sur les marchés de capitaux.</a:t>
-            </a:r>
-          </a:p>
-        </p:txBody>
-      </p:sp>
-      <p:sp>
-        <p:nvSpPr>
-          <p:cNvPr id="23" name="Rectangle 22"/>
+          <p:cNvPr id="21" name="Rectangle 20"/>
           <p:cNvSpPr/>
           <p:nvPr/>
         </p:nvSpPr>
         <p:spPr>
           <a:xfrm>
-            <a:off x="360000" y="2898000"/>
-            <a:ext cx="28800" cy="486000"/>
+            <a:off x="324000" y="2268000"/>
+            <a:ext cx="4932000" cy="198000"/>
           </a:xfrm>
           <a:prstGeom prst="rect">
             <a:avLst/>
           </a:prstGeom>
           <a:solidFill>
-            <a:srgbClr val="1A7A4A"/>
+            <a:srgbClr val="1B3A6B"/>
           </a:solidFill>
           <a:ln>
             <a:noFill/>
@@ -27631,14 +27563,14 @@
       </p:sp>
       <p:sp>
         <p:nvSpPr>
-          <p:cNvPr id="24" name="TextBox 23"/>
+          <p:cNvPr id="22" name="TextBox 21"/>
           <p:cNvSpPr txBox="1"/>
           <p:nvPr/>
         </p:nvSpPr>
         <p:spPr>
           <a:xfrm>
-            <a:off x="468000" y="2898000"/>
-            <a:ext cx="4716000" cy="162000"/>
+            <a:off x="396000" y="2296800"/>
+            <a:ext cx="4788000" cy="162000"/>
           </a:xfrm>
           <a:prstGeom prst="rect">
             <a:avLst/>
@@ -27653,66 +27585,32 @@
           <a:p>
             <a:pPr algn="l"/>
             <a:r>
-              <a:rPr sz="850" b="1" i="0">
-                <a:solidFill>
-                  <a:srgbClr val="1B3A6B"/>
+              <a:rPr sz="900" b="1" i="0">
+                <a:solidFill>
+                  <a:srgbClr val="FFFFFF"/>
                 </a:solidFill>
               </a:rPr>
-              <a:t>Réglementation</a:t>
-            </a:r>
-          </a:p>
-        </p:txBody>
-      </p:sp>
-      <p:sp>
-        <p:nvSpPr>
-          <p:cNvPr id="25" name="TextBox 24"/>
-          <p:cNvSpPr txBox="1"/>
-          <p:nvPr/>
-        </p:nvSpPr>
-        <p:spPr>
-          <a:xfrm>
-            <a:off x="468000" y="3060000"/>
-            <a:ext cx="4716000" cy="378000"/>
-          </a:xfrm>
-          <a:prstGeom prst="rect">
-            <a:avLst/>
-          </a:prstGeom>
-          <a:noFill/>
-        </p:spPr>
-        <p:txBody>
-          <a:bodyPr wrap="square">
-            <a:spAutoFit/>
-          </a:bodyPr>
-          <a:lstStyle/>
-          <a:p>
-            <a:pPr algn="l"/>
-            <a:r>
-              <a:rPr sz="800" b="0" i="0">
-                <a:solidFill>
-                  <a:srgbClr val="555555"/>
-                </a:solidFill>
-              </a:rPr>
-              <a:t>L'assouplissement progressif des règles de Bâle IV en Europe et aux États-Unis pourrait réduire les coûts en capital pour les banques d'investissement comme GS et MS.</a:t>
-            </a:r>
-          </a:p>
-        </p:txBody>
-      </p:sp>
-      <p:sp>
-        <p:nvSpPr>
-          <p:cNvPr id="26" name="Rectangle 25"/>
+              <a:t>CATALYSEURS CLÉS</a:t>
+            </a:r>
+          </a:p>
+        </p:txBody>
+      </p:sp>
+      <p:sp>
+        <p:nvSpPr>
+          <p:cNvPr id="23" name="Rectangle 22"/>
           <p:cNvSpPr/>
           <p:nvPr/>
         </p:nvSpPr>
         <p:spPr>
           <a:xfrm>
-            <a:off x="360000" y="3438000"/>
-            <a:ext cx="28800" cy="486000"/>
+            <a:off x="396000" y="2520000"/>
+            <a:ext cx="43200" cy="666000"/>
           </a:xfrm>
           <a:prstGeom prst="rect">
             <a:avLst/>
           </a:prstGeom>
           <a:solidFill>
-            <a:srgbClr val="1A7A4A"/>
+            <a:srgbClr val="1B3A6B"/>
           </a:solidFill>
           <a:ln>
             <a:noFill/>
@@ -27742,14 +27640,14 @@
       </p:sp>
       <p:sp>
         <p:nvSpPr>
-          <p:cNvPr id="27" name="TextBox 26"/>
+          <p:cNvPr id="24" name="TextBox 23"/>
           <p:cNvSpPr txBox="1"/>
           <p:nvPr/>
         </p:nvSpPr>
         <p:spPr>
           <a:xfrm>
-            <a:off x="468000" y="3438000"/>
-            <a:ext cx="4716000" cy="162000"/>
+            <a:off x="503999" y="2538000"/>
+            <a:ext cx="4680000" cy="162000"/>
           </a:xfrm>
           <a:prstGeom prst="rect">
             <a:avLst/>
@@ -27764,26 +27662,26 @@
           <a:p>
             <a:pPr algn="l"/>
             <a:r>
-              <a:rPr sz="850" b="1" i="0">
+              <a:rPr sz="1000" b="1" i="0">
                 <a:solidFill>
                   <a:srgbClr val="1B3A6B"/>
                 </a:solidFill>
               </a:rPr>
-              <a:t>Technologie</a:t>
-            </a:r>
-          </a:p>
-        </p:txBody>
-      </p:sp>
-      <p:sp>
-        <p:nvSpPr>
-          <p:cNvPr id="28" name="TextBox 27"/>
+              <a:t>Taux Directeurs Élevés</a:t>
+            </a:r>
+          </a:p>
+        </p:txBody>
+      </p:sp>
+      <p:sp>
+        <p:nvSpPr>
+          <p:cNvPr id="25" name="TextBox 24"/>
           <p:cNvSpPr txBox="1"/>
           <p:nvPr/>
         </p:nvSpPr>
         <p:spPr>
           <a:xfrm>
-            <a:off x="468000" y="3600000"/>
-            <a:ext cx="4716000" cy="378000"/>
+            <a:off x="503999" y="2718000"/>
+            <a:ext cx="4680000" cy="450000"/>
           </a:xfrm>
           <a:prstGeom prst="rect">
             <a:avLst/>
@@ -27798,19 +27696,241 @@
           <a:p>
             <a:pPr algn="l"/>
             <a:r>
-              <a:rPr sz="800" b="0" i="0">
+              <a:rPr sz="900" b="0" i="0">
                 <a:solidFill>
                   <a:srgbClr val="555555"/>
                 </a:solidFill>
               </a:rPr>
-              <a:t>L'adoption accélérée de l'IA et des solutions cloud dans les services financiers optimise les coûts opérationnels et améliore l'efficacité des plateformes de trading.</a:t>
+              <a:t>Maintien des taux BCE a 3 % — soutien structurel aux NIM bancaires et a la rentabilité des depots.</a:t>
+            </a:r>
+          </a:p>
+        </p:txBody>
+      </p:sp>
+      <p:sp>
+        <p:nvSpPr>
+          <p:cNvPr id="26" name="Rectangle 25"/>
+          <p:cNvSpPr/>
+          <p:nvPr/>
+        </p:nvSpPr>
+        <p:spPr>
+          <a:xfrm>
+            <a:off x="396000" y="3221999"/>
+            <a:ext cx="43200" cy="666000"/>
+          </a:xfrm>
+          <a:prstGeom prst="rect">
+            <a:avLst/>
+          </a:prstGeom>
+          <a:solidFill>
+            <a:srgbClr val="1B3A6B"/>
+          </a:solidFill>
+          <a:ln>
+            <a:noFill/>
+          </a:ln>
+        </p:spPr>
+        <p:style>
+          <a:lnRef idx="1">
+            <a:schemeClr val="accent1"/>
+          </a:lnRef>
+          <a:fillRef idx="3">
+            <a:schemeClr val="accent1"/>
+          </a:fillRef>
+          <a:effectRef idx="2">
+            <a:schemeClr val="accent1"/>
+          </a:effectRef>
+          <a:fontRef idx="minor">
+            <a:schemeClr val="lt1"/>
+          </a:fontRef>
+        </p:style>
+        <p:txBody>
+          <a:bodyPr rtlCol="0" anchor="ctr"/>
+          <a:lstStyle/>
+          <a:p>
+            <a:pPr algn="ctr"/>
+          </a:p>
+        </p:txBody>
+      </p:sp>
+      <p:sp>
+        <p:nvSpPr>
+          <p:cNvPr id="27" name="TextBox 26"/>
+          <p:cNvSpPr txBox="1"/>
+          <p:nvPr/>
+        </p:nvSpPr>
+        <p:spPr>
+          <a:xfrm>
+            <a:off x="503999" y="3240000"/>
+            <a:ext cx="4680000" cy="162000"/>
+          </a:xfrm>
+          <a:prstGeom prst="rect">
+            <a:avLst/>
+          </a:prstGeom>
+          <a:noFill/>
+        </p:spPr>
+        <p:txBody>
+          <a:bodyPr wrap="square">
+            <a:spAutoFit/>
+          </a:bodyPr>
+          <a:lstStyle/>
+          <a:p>
+            <a:pPr algn="l"/>
+            <a:r>
+              <a:rPr sz="1000" b="1" i="0">
+                <a:solidFill>
+                  <a:srgbClr val="1B3A6B"/>
+                </a:solidFill>
+              </a:rPr>
+              <a:t>Consolidation Sectorielle</a:t>
+            </a:r>
+          </a:p>
+        </p:txBody>
+      </p:sp>
+      <p:sp>
+        <p:nvSpPr>
+          <p:cNvPr id="28" name="TextBox 27"/>
+          <p:cNvSpPr txBox="1"/>
+          <p:nvPr/>
+        </p:nvSpPr>
+        <p:spPr>
+          <a:xfrm>
+            <a:off x="503999" y="3420000"/>
+            <a:ext cx="4680000" cy="450000"/>
+          </a:xfrm>
+          <a:prstGeom prst="rect">
+            <a:avLst/>
+          </a:prstGeom>
+          <a:noFill/>
+        </p:spPr>
+        <p:txBody>
+          <a:bodyPr wrap="square">
+            <a:spAutoFit/>
+          </a:bodyPr>
+          <a:lstStyle/>
+          <a:p>
+            <a:pPr algn="l"/>
+            <a:r>
+              <a:rPr sz="900" b="0" i="0">
+                <a:solidFill>
+                  <a:srgbClr val="555555"/>
+                </a:solidFill>
+              </a:rPr>
+              <a:t>Fusions-acquisitions dans la banque retail — prime de contrôle sur les cibles sous-valorisees.</a:t>
+            </a:r>
+          </a:p>
+        </p:txBody>
+      </p:sp>
+      <p:sp>
+        <p:nvSpPr>
+          <p:cNvPr id="29" name="Rectangle 28"/>
+          <p:cNvSpPr/>
+          <p:nvPr/>
+        </p:nvSpPr>
+        <p:spPr>
+          <a:xfrm>
+            <a:off x="396000" y="3924000"/>
+            <a:ext cx="43200" cy="666000"/>
+          </a:xfrm>
+          <a:prstGeom prst="rect">
+            <a:avLst/>
+          </a:prstGeom>
+          <a:solidFill>
+            <a:srgbClr val="1B3A6B"/>
+          </a:solidFill>
+          <a:ln>
+            <a:noFill/>
+          </a:ln>
+        </p:spPr>
+        <p:style>
+          <a:lnRef idx="1">
+            <a:schemeClr val="accent1"/>
+          </a:lnRef>
+          <a:fillRef idx="3">
+            <a:schemeClr val="accent1"/>
+          </a:fillRef>
+          <a:effectRef idx="2">
+            <a:schemeClr val="accent1"/>
+          </a:effectRef>
+          <a:fontRef idx="minor">
+            <a:schemeClr val="lt1"/>
+          </a:fontRef>
+        </p:style>
+        <p:txBody>
+          <a:bodyPr rtlCol="0" anchor="ctr"/>
+          <a:lstStyle/>
+          <a:p>
+            <a:pPr algn="ctr"/>
+          </a:p>
+        </p:txBody>
+      </p:sp>
+      <p:sp>
+        <p:nvSpPr>
+          <p:cNvPr id="30" name="TextBox 29"/>
+          <p:cNvSpPr txBox="1"/>
+          <p:nvPr/>
+        </p:nvSpPr>
+        <p:spPr>
+          <a:xfrm>
+            <a:off x="503999" y="3942000"/>
+            <a:ext cx="4680000" cy="162000"/>
+          </a:xfrm>
+          <a:prstGeom prst="rect">
+            <a:avLst/>
+          </a:prstGeom>
+          <a:noFill/>
+        </p:spPr>
+        <p:txBody>
+          <a:bodyPr wrap="square">
+            <a:spAutoFit/>
+          </a:bodyPr>
+          <a:lstStyle/>
+          <a:p>
+            <a:pPr algn="l"/>
+            <a:r>
+              <a:rPr sz="1000" b="1" i="0">
+                <a:solidFill>
+                  <a:srgbClr val="1B3A6B"/>
+                </a:solidFill>
+              </a:rPr>
+              <a:t>Digitalisation Services</a:t>
+            </a:r>
+          </a:p>
+        </p:txBody>
+      </p:sp>
+      <p:sp>
+        <p:nvSpPr>
+          <p:cNvPr id="31" name="TextBox 30"/>
+          <p:cNvSpPr txBox="1"/>
+          <p:nvPr/>
+        </p:nvSpPr>
+        <p:spPr>
+          <a:xfrm>
+            <a:off x="503999" y="4122000"/>
+            <a:ext cx="4680000" cy="450000"/>
+          </a:xfrm>
+          <a:prstGeom prst="rect">
+            <a:avLst/>
+          </a:prstGeom>
+          <a:noFill/>
+        </p:spPr>
+        <p:txBody>
+          <a:bodyPr wrap="square">
+            <a:spAutoFit/>
+          </a:bodyPr>
+          <a:lstStyle/>
+          <a:p>
+            <a:pPr algn="l"/>
+            <a:r>
+              <a:rPr sz="900" b="0" i="0">
+                <a:solidFill>
+                  <a:srgbClr val="555555"/>
+                </a:solidFill>
+              </a:rPr>
+              <a:t>Plateformes wealth management numeriques — réduction Coûts et captation millennials investisseurs.</a:t>
             </a:r>
           </a:p>
         </p:txBody>
       </p:sp>
       <p:graphicFrame>
         <p:nvGraphicFramePr>
-          <p:cNvPr id="29" name="Table 28"/>
+          <p:cNvPr id="32" name="Table 31"/>
           <p:cNvGraphicFramePr>
             <a:graphicFrameLocks noGrp="1"/>
           </p:cNvGraphicFramePr>
@@ -27932,7 +28052,7 @@
                             <a:srgbClr val="1A1A1A"/>
                           </a:solidFill>
                         </a:rPr>
-                        <a:t>16.7x</a:t>
+                        <a:t>17.1x</a:t>
                       </a:r>
                     </a:p>
                   </a:txBody>
@@ -28126,7 +28246,7 @@
                             <a:srgbClr val="1A1A1A"/>
                           </a:solidFill>
                         </a:rPr>
-                        <a:t>+39.3 %</a:t>
+                        <a:t>+37.5 %</a:t>
                       </a:r>
                     </a:p>
                   </a:txBody>
@@ -28295,7 +28415,7 @@
       </p:graphicFrame>
       <p:sp>
         <p:nvSpPr>
-          <p:cNvPr id="30" name="Rectangle 29"/>
+          <p:cNvPr id="33" name="Rectangle 32"/>
           <p:cNvSpPr/>
           <p:nvPr/>
         </p:nvSpPr>
@@ -28338,7 +28458,7 @@
       </p:sp>
       <p:sp>
         <p:nvSpPr>
-          <p:cNvPr id="31" name="TextBox 30"/>
+          <p:cNvPr id="34" name="TextBox 33"/>
           <p:cNvSpPr txBox="1"/>
           <p:nvPr/>
         </p:nvSpPr>
@@ -29120,7 +29240,7 @@
                             <a:srgbClr val="1A1A1A"/>
                           </a:solidFill>
                         </a:rPr>
-                        <a:t>0.8x</a:t>
+                        <a:t>0.7x</a:t>
                       </a:r>
                     </a:p>
                   </a:txBody>
@@ -29140,7 +29260,7 @@
                             <a:srgbClr val="1A1A1A"/>
                           </a:solidFill>
                         </a:rPr>
-                        <a:t>17.3x</a:t>
+                        <a:t>16.3x</a:t>
                       </a:r>
                     </a:p>
                   </a:txBody>
@@ -29266,7 +29386,7 @@
                             <a:srgbClr val="1A1A1A"/>
                           </a:solidFill>
                         </a:rPr>
-                        <a:t>2.9x</a:t>
+                        <a:t>3.0x</a:t>
                       </a:r>
                     </a:p>
                   </a:txBody>
@@ -29288,7 +29408,7 @@
                             <a:srgbClr val="1A1A1A"/>
                           </a:solidFill>
                         </a:rPr>
-                        <a:t>17.5x</a:t>
+                        <a:t>17.7x</a:t>
                       </a:r>
                     </a:p>
                   </a:txBody>
@@ -29438,7 +29558,7 @@
                             <a:srgbClr val="1A1A1A"/>
                           </a:solidFill>
                         </a:rPr>
-                        <a:t>17.9x</a:t>
+                        <a:t>18.0x</a:t>
                       </a:r>
                     </a:p>
                   </a:txBody>
@@ -29564,7 +29684,7 @@
                             <a:srgbClr val="1A1A1A"/>
                           </a:solidFill>
                         </a:rPr>
-                        <a:t>3.7x</a:t>
+                        <a:t>3.8x</a:t>
                       </a:r>
                     </a:p>
                   </a:txBody>
@@ -29586,7 +29706,7 @@
                             <a:srgbClr val="1A1A1A"/>
                           </a:solidFill>
                         </a:rPr>
-                        <a:t>13.9x</a:t>
+                        <a:t>14.0x</a:t>
                       </a:r>
                     </a:p>
                   </a:txBody>
@@ -29736,7 +29856,7 @@
                             <a:srgbClr val="1A1A1A"/>
                           </a:solidFill>
                         </a:rPr>
-                        <a:t>13.7x</a:t>
+                        <a:t>13.8x</a:t>
                       </a:r>
                     </a:p>
                   </a:txBody>
@@ -29862,7 +29982,7 @@
                             <a:srgbClr val="1A1A1A"/>
                           </a:solidFill>
                         </a:rPr>
-                        <a:t>3.5x</a:t>
+                        <a:t>3.6x</a:t>
                       </a:r>
                     </a:p>
                   </a:txBody>
@@ -29884,7 +30004,7 @@
                             <a:srgbClr val="1A1A1A"/>
                           </a:solidFill>
                         </a:rPr>
-                        <a:t>20.7x</a:t>
+                        <a:t>21.1x</a:t>
                       </a:r>
                     </a:p>
                   </a:txBody>
@@ -29994,7 +30114,7 @@
                             <a:srgbClr val="1A1A1A"/>
                           </a:solidFill>
                         </a:rPr>
-                        <a:t>16.7x</a:t>
+                        <a:t>17.1x</a:t>
                       </a:r>
                     </a:p>
                   </a:txBody>
@@ -30014,7 +30134,7 @@
                             <a:srgbClr val="1A1A1A"/>
                           </a:solidFill>
                         </a:rPr>
-                        <a:t>6.7x</a:t>
+                        <a:t>6.8x</a:t>
                       </a:r>
                     </a:p>
                   </a:txBody>
@@ -30034,7 +30154,7 @@
                             <a:srgbClr val="1A1A1A"/>
                           </a:solidFill>
                         </a:rPr>
-                        <a:t>28.6x</a:t>
+                        <a:t>29.0x</a:t>
                       </a:r>
                     </a:p>
                   </a:txBody>
@@ -30160,7 +30280,7 @@
                             <a:srgbClr val="1A1A1A"/>
                           </a:solidFill>
                         </a:rPr>
-                        <a:t>3.5x</a:t>
+                        <a:t>3.6x</a:t>
                       </a:r>
                     </a:p>
                   </a:txBody>
@@ -30182,7 +30302,7 @@
                             <a:srgbClr val="1A1A1A"/>
                           </a:solidFill>
                         </a:rPr>
-                        <a:t>15.5x</a:t>
+                        <a:t>15.7x</a:t>
                       </a:r>
                     </a:p>
                   </a:txBody>
@@ -30292,7 +30412,7 @@
                             <a:srgbClr val="1A1A1A"/>
                           </a:solidFill>
                         </a:rPr>
-                        <a:t>16.7x</a:t>
+                        <a:t>17.1x</a:t>
                       </a:r>
                     </a:p>
                   </a:txBody>
@@ -30332,7 +30452,7 @@
                             <a:srgbClr val="1A1A1A"/>
                           </a:solidFill>
                         </a:rPr>
-                        <a:t>17.4x</a:t>
+                        <a:t>17.0x</a:t>
                       </a:r>
                     </a:p>
                   </a:txBody>
@@ -30554,7 +30674,7 @@
                   <a:srgbClr val="555555"/>
                 </a:solidFill>
               </a:rPr>
-              <a:t>La Médiane EV/EBITDA sectorielle s établit a 16.7x LTM. The Goldman Sachs Gr (—) se distingue comme le leader de qualité, combine a une marge EBITDA de 0.0 % et une croissance de +15.2 %. La dispersion des multiples revele l hétérogèneite des profils au sein du secteur Services Financiers — une lecture croisée P/E vs EV/EBITDA permet d isoler les effets de structure de capital et les distorsions comptables.</a:t>
+              <a:t>La Médiane EV/EBITDA sectorielle s établit a 17.1x LTM. The Goldman Sachs Gr (—) se distingue comme le leader de qualité, combine a une marge EBITDA de 0.0 % et une croissance de +15.2 %. La dispersion des multiples revele l hétérogèneite des profils au sein du secteur Services Financiers — une lecture croisée P/E vs EV/EBITDA permet d isoler les effets de structure de capital et les distorsions comptables.</a:t>
             </a:r>
           </a:p>
         </p:txBody>
@@ -31299,7 +31419,7 @@
                   <a:srgbClr val="1B3A6B"/>
                 </a:solidFill>
               </a:rPr>
-              <a:t>Marge d'intérêt nette</a:t>
+              <a:t>Marge Nette d'Intérêt</a:t>
             </a:r>
           </a:p>
         </p:txBody>
@@ -31333,7 +31453,7 @@
                   <a:srgbClr val="555555"/>
                 </a:solidFill>
               </a:rPr>
-              <a:t>La normalisation des courbes de taux devrait améliorer la marge d'intérêt nette pour les banques commerciales, soutenant la rentabilité.</a:t>
+              <a:t>Taux élevés soutiennent les NIM — pic attendu T2 2026</a:t>
             </a:r>
           </a:p>
         </p:txBody>
@@ -31487,7 +31607,7 @@
                   <a:srgbClr val="1B3A6B"/>
                 </a:solidFill>
               </a:rPr>
-              <a:t>Volumes de M&amp;A</a:t>
+              <a:t>Gestion d'Actifs</a:t>
             </a:r>
           </a:p>
         </p:txBody>
@@ -31521,7 +31641,7 @@
                   <a:srgbClr val="555555"/>
                 </a:solidFill>
               </a:rPr>
-              <a:t>Les niveaux élevés de liquidités corporatives et les valorisations attractives des actifs devraient stimuler l'activité de fusions-acquisitions.</a:t>
+              <a:t>Collecte nette positive — Marchés actions porteurs</a:t>
             </a:r>
           </a:p>
         </p:txBody>
@@ -31675,7 +31795,7 @@
                   <a:srgbClr val="1B3A6B"/>
                 </a:solidFill>
               </a:rPr>
-              <a:t>Coûts de conformité</a:t>
+              <a:t>Coût du Risque</a:t>
             </a:r>
           </a:p>
         </p:txBody>
@@ -31709,7 +31829,7 @@
                   <a:srgbClr val="555555"/>
                 </a:solidFill>
               </a:rPr>
-              <a:t>La pression réglementaire persistante pourrait continuer à peser sur les marges des banques d'investissement malgré les gains d'efficacité.</a:t>
+              <a:t>Montee progressive des provisions — NPL en hausse</a:t>
             </a:r>
           </a:p>
         </p:txBody>
@@ -31863,7 +31983,7 @@
                   <a:srgbClr val="1B3A6B"/>
                 </a:solidFill>
               </a:rPr>
-              <a:t>Concurrence FinTech</a:t>
+              <a:t>Régulation</a:t>
             </a:r>
           </a:p>
         </p:txBody>
@@ -31897,7 +32017,7 @@
                   <a:srgbClr val="555555"/>
                 </a:solidFill>
               </a:rPr>
-              <a:t>L'émergence de néobanques et de solutions de paiement alternatives limite la croissance organique des revenus traditionnels des banques.</a:t>
+              <a:t>Bale IV — impact CET1 estime a -80bps grandes banques EU</a:t>
             </a:r>
           </a:p>
         </p:txBody>
@@ -32221,7 +32341,7 @@
                   <a:srgbClr val="2A5298"/>
                 </a:solidFill>
               </a:rPr>
-              <a:t>Le secteur semble en phase de reprise modérée, avec une croissance des revenus soutenue par la résilience des marchés actions et une demande résiduelle de crédit.</a:t>
+              <a:t>Secteur en maturité cyclique | NIM en pic, qualité d'actif à surveiller</a:t>
             </a:r>
           </a:p>
         </p:txBody>
@@ -32229,6 +32349,151 @@
       <p:sp>
         <p:nvSpPr>
           <p:cNvPr id="44" name="Rectangle 43"/>
+          <p:cNvSpPr/>
+          <p:nvPr/>
+        </p:nvSpPr>
+        <p:spPr>
+          <a:xfrm>
+            <a:off x="6083999" y="4031999"/>
+            <a:ext cx="2628000" cy="18000"/>
+          </a:xfrm>
+          <a:prstGeom prst="rect">
+            <a:avLst/>
+          </a:prstGeom>
+          <a:solidFill>
+            <a:srgbClr val="AAAAAA"/>
+          </a:solidFill>
+          <a:ln>
+            <a:noFill/>
+          </a:ln>
+        </p:spPr>
+        <p:style>
+          <a:lnRef idx="1">
+            <a:schemeClr val="accent1"/>
+          </a:lnRef>
+          <a:fillRef idx="3">
+            <a:schemeClr val="accent1"/>
+          </a:fillRef>
+          <a:effectRef idx="2">
+            <a:schemeClr val="accent1"/>
+          </a:effectRef>
+          <a:fontRef idx="minor">
+            <a:schemeClr val="lt1"/>
+          </a:fontRef>
+        </p:style>
+        <p:txBody>
+          <a:bodyPr rtlCol="0" anchor="ctr"/>
+          <a:lstStyle/>
+          <a:p>
+            <a:pPr algn="ctr"/>
+          </a:p>
+        </p:txBody>
+      </p:sp>
+      <p:sp>
+        <p:nvSpPr>
+          <p:cNvPr id="45" name="TextBox 44"/>
+          <p:cNvSpPr txBox="1"/>
+          <p:nvPr/>
+        </p:nvSpPr>
+        <p:spPr>
+          <a:xfrm>
+            <a:off x="5976000" y="4086000"/>
+            <a:ext cx="2844000" cy="180000"/>
+          </a:xfrm>
+          <a:prstGeom prst="rect">
+            <a:avLst/>
+          </a:prstGeom>
+          <a:noFill/>
+        </p:spPr>
+        <p:txBody>
+          <a:bodyPr wrap="square">
+            <a:spAutoFit/>
+          </a:bodyPr>
+          <a:lstStyle/>
+          <a:p>
+            <a:pPr algn="ctr"/>
+            <a:r>
+              <a:rPr sz="700" b="1" i="0">
+                <a:solidFill>
+                  <a:srgbClr val="AAAAAA"/>
+                </a:solidFill>
+              </a:rPr>
+              <a:t>CONTEXTE MACRO</a:t>
+            </a:r>
+          </a:p>
+        </p:txBody>
+      </p:sp>
+      <p:sp>
+        <p:nvSpPr>
+          <p:cNvPr id="46" name="TextBox 45"/>
+          <p:cNvSpPr txBox="1"/>
+          <p:nvPr/>
+        </p:nvSpPr>
+        <p:spPr>
+          <a:xfrm>
+            <a:off x="5976000" y="4266000"/>
+            <a:ext cx="2844000" cy="198000"/>
+          </a:xfrm>
+          <a:prstGeom prst="rect">
+            <a:avLst/>
+          </a:prstGeom>
+          <a:noFill/>
+        </p:spPr>
+        <p:txBody>
+          <a:bodyPr wrap="square">
+            <a:spAutoFit/>
+          </a:bodyPr>
+          <a:lstStyle/>
+          <a:p>
+            <a:pPr algn="ctr"/>
+            <a:r>
+              <a:rPr sz="850" b="1" i="0">
+                <a:solidFill>
+                  <a:srgbClr val="1A7A4A"/>
+                </a:solidFill>
+              </a:rPr>
+              <a:t>Régime : Bull</a:t>
+            </a:r>
+          </a:p>
+        </p:txBody>
+      </p:sp>
+      <p:sp>
+        <p:nvSpPr>
+          <p:cNvPr id="47" name="TextBox 46"/>
+          <p:cNvSpPr txBox="1"/>
+          <p:nvPr/>
+        </p:nvSpPr>
+        <p:spPr>
+          <a:xfrm>
+            <a:off x="5976000" y="4482000"/>
+            <a:ext cx="2844000" cy="180000"/>
+          </a:xfrm>
+          <a:prstGeom prst="rect">
+            <a:avLst/>
+          </a:prstGeom>
+          <a:noFill/>
+        </p:spPr>
+        <p:txBody>
+          <a:bodyPr wrap="square">
+            <a:spAutoFit/>
+          </a:bodyPr>
+          <a:lstStyle/>
+          <a:p>
+            <a:pPr algn="ctr"/>
+            <a:r>
+              <a:rPr sz="750" b="0" i="0">
+                <a:solidFill>
+                  <a:srgbClr val="555555"/>
+                </a:solidFill>
+              </a:rPr>
+              <a:t>Rec. 6M : 10%  (Faible)</a:t>
+            </a:r>
+          </a:p>
+        </p:txBody>
+      </p:sp>
+      <p:sp>
+        <p:nvSpPr>
+          <p:cNvPr id="48" name="Rectangle 47"/>
           <p:cNvSpPr/>
           <p:nvPr/>
         </p:nvSpPr>
@@ -32271,7 +32536,7 @@
       </p:sp>
       <p:sp>
         <p:nvSpPr>
-          <p:cNvPr id="45" name="TextBox 44"/>
+          <p:cNvPr id="49" name="TextBox 48"/>
           <p:cNvSpPr txBox="1"/>
           <p:nvPr/>
         </p:nvSpPr>
@@ -33190,7 +33455,7 @@
                             <a:srgbClr val="1A1A1A"/>
                           </a:solidFill>
                         </a:rPr>
-                        <a:t>+71.4%</a:t>
+                        <a:t>+69.7%</a:t>
                       </a:r>
                     </a:p>
                   </a:txBody>
@@ -33368,7 +33633,7 @@
                             <a:srgbClr val="1A1A1A"/>
                           </a:solidFill>
                         </a:rPr>
-                        <a:t>+39.3%</a:t>
+                        <a:t>+37.5%</a:t>
                       </a:r>
                     </a:p>
                   </a:txBody>
@@ -33546,7 +33811,7 @@
                             <a:srgbClr val="1A1A1A"/>
                           </a:solidFill>
                         </a:rPr>
-                        <a:t>+22.8%</a:t>
+                        <a:t>+25.6%</a:t>
                       </a:r>
                     </a:p>
                   </a:txBody>
@@ -33658,7 +33923,7 @@
                             <a:srgbClr val="1A1A1A"/>
                           </a:solidFill>
                         </a:rPr>
-                        <a:t>16.7x</a:t>
+                        <a:t>17.1x</a:t>
                       </a:r>
                     </a:p>
                   </a:txBody>
@@ -33724,7 +33989,7 @@
                             <a:srgbClr val="1A1A1A"/>
                           </a:solidFill>
                         </a:rPr>
-                        <a:t>+12.3%</a:t>
+                        <a:t>+15.2%</a:t>
                       </a:r>
                     </a:p>
                   </a:txBody>
@@ -33747,8 +34012,85 @@
         </p:nvSpPr>
         <p:spPr>
           <a:xfrm>
-            <a:off x="324000" y="1666800"/>
-            <a:ext cx="2700000" cy="162000"/>
+            <a:off x="324000" y="1792800"/>
+            <a:ext cx="8496000" cy="234000"/>
+          </a:xfrm>
+          <a:prstGeom prst="rect">
+            <a:avLst/>
+          </a:prstGeom>
+          <a:solidFill>
+            <a:srgbClr val="1B3A6B"/>
+          </a:solidFill>
+          <a:ln>
+            <a:noFill/>
+          </a:ln>
+        </p:spPr>
+        <p:style>
+          <a:lnRef idx="1">
+            <a:schemeClr val="accent1"/>
+          </a:lnRef>
+          <a:fillRef idx="3">
+            <a:schemeClr val="accent1"/>
+          </a:fillRef>
+          <a:effectRef idx="2">
+            <a:schemeClr val="accent1"/>
+          </a:effectRef>
+          <a:fontRef idx="minor">
+            <a:schemeClr val="lt1"/>
+          </a:fontRef>
+        </p:style>
+        <p:txBody>
+          <a:bodyPr rtlCol="0" anchor="ctr"/>
+          <a:lstStyle/>
+          <a:p>
+            <a:pPr algn="ctr"/>
+          </a:p>
+        </p:txBody>
+      </p:sp>
+      <p:sp>
+        <p:nvSpPr>
+          <p:cNvPr id="17" name="TextBox 16"/>
+          <p:cNvSpPr txBox="1"/>
+          <p:nvPr/>
+        </p:nvSpPr>
+        <p:spPr>
+          <a:xfrm>
+            <a:off x="396000" y="1839600"/>
+            <a:ext cx="8352000" cy="162000"/>
+          </a:xfrm>
+          <a:prstGeom prst="rect">
+            <a:avLst/>
+          </a:prstGeom>
+          <a:noFill/>
+        </p:spPr>
+        <p:txBody>
+          <a:bodyPr wrap="square">
+            <a:spAutoFit/>
+          </a:bodyPr>
+          <a:lstStyle/>
+          <a:p>
+            <a:pPr algn="l"/>
+            <a:r>
+              <a:rPr sz="1000" b="1" i="0">
+                <a:solidFill>
+                  <a:srgbClr val="FFFFFF"/>
+                </a:solidFill>
+              </a:rPr>
+              <a:t>LEADERSHIP CAPITAL MARKETS — score 88/100</a:t>
+            </a:r>
+          </a:p>
+        </p:txBody>
+      </p:sp>
+      <p:sp>
+        <p:nvSpPr>
+          <p:cNvPr id="18" name="Rectangle 17"/>
+          <p:cNvSpPr/>
+          <p:nvPr/>
+        </p:nvSpPr>
+        <p:spPr>
+          <a:xfrm>
+            <a:off x="324000" y="2080800"/>
+            <a:ext cx="8496000" cy="1620000"/>
           </a:xfrm>
           <a:prstGeom prst="rect">
             <a:avLst/>
@@ -33784,20 +34126,20 @@
       </p:sp>
       <p:sp>
         <p:nvSpPr>
-          <p:cNvPr id="17" name="Rectangle 16"/>
+          <p:cNvPr id="19" name="Rectangle 18"/>
           <p:cNvSpPr/>
           <p:nvPr/>
         </p:nvSpPr>
         <p:spPr>
           <a:xfrm>
-            <a:off x="324000" y="1666800"/>
-            <a:ext cx="43200" cy="162000"/>
+            <a:off x="324000" y="2080800"/>
+            <a:ext cx="43200" cy="1620000"/>
           </a:xfrm>
           <a:prstGeom prst="rect">
             <a:avLst/>
           </a:prstGeom>
           <a:solidFill>
-            <a:srgbClr val="2A5298"/>
+            <a:srgbClr val="1B3A6B"/>
           </a:solidFill>
           <a:ln>
             <a:noFill/>
@@ -33827,14 +34169,14 @@
       </p:sp>
       <p:sp>
         <p:nvSpPr>
-          <p:cNvPr id="18" name="TextBox 17"/>
+          <p:cNvPr id="20" name="TextBox 19"/>
           <p:cNvSpPr txBox="1"/>
           <p:nvPr/>
         </p:nvSpPr>
         <p:spPr>
           <a:xfrm>
-            <a:off x="413999" y="1684800"/>
-            <a:ext cx="2520000" cy="136800"/>
+            <a:off x="432000" y="2134800"/>
+            <a:ext cx="8424000" cy="1530000"/>
           </a:xfrm>
           <a:prstGeom prst="rect">
             <a:avLst/>
@@ -33849,61 +34191,26 @@
           <a:p>
             <a:pPr algn="l"/>
             <a:r>
-              <a:rPr sz="800" b="1" i="0">
-                <a:solidFill>
-                  <a:srgbClr val="1B3A6B"/>
+              <a:rPr sz="900" b="0" i="0">
+                <a:solidFill>
+                  <a:srgbClr val="555555"/>
                 </a:solidFill>
               </a:rPr>
-              <a:t>Capital Markets — Surpondérer</a:t>
-            </a:r>
-          </a:p>
-        </p:txBody>
-      </p:sp>
-      <p:sp>
-        <p:nvSpPr>
-          <p:cNvPr id="19" name="TextBox 18"/>
-          <p:cNvSpPr txBox="1"/>
-          <p:nvPr/>
-        </p:nvSpPr>
-        <p:spPr>
-          <a:xfrm>
-            <a:off x="413999" y="1846800"/>
-            <a:ext cx="2520000" cy="900000"/>
-          </a:xfrm>
-          <a:prstGeom prst="rect">
-            <a:avLst/>
-          </a:prstGeom>
-          <a:noFill/>
-        </p:spPr>
-        <p:txBody>
-          <a:bodyPr wrap="square">
-            <a:spAutoFit/>
-          </a:bodyPr>
-          <a:lstStyle/>
-          <a:p>
-            <a:pPr algn="l"/>
-            <a:r>
-              <a:rPr sz="750" b="0" i="0">
-                <a:solidFill>
-                  <a:srgbClr val="555555"/>
-                </a:solidFill>
-              </a:rPr>
-              <a:t>• GS (90/100)
-• MS (86/100)</a:t>
-            </a:r>
-          </a:p>
-        </p:txBody>
-      </p:sp>
-      <p:sp>
-        <p:nvSpPr>
-          <p:cNvPr id="20" name="Rectangle 19"/>
+              <a:t>Le sous-segment Capital Markets ressort en tête du classement avec un score composite de 88/100 et un signal surpondérer, porté par 2 acteurs dont GS, MS. La valorisation médiane ressort sur des metriques de valorisation specifiques au secteur (ratios financiers) et une trajectoire top-line à +13.1% YoY. À l'inverse, Asset Management ferme la Marché (75/100, signal surpondérer), reflétant des fondamentaux sous pression ou une valorisation déjà tendue. L'écart de 13 points entre les extrêmes du classement justifie une approche sélective plutôt qu'une exposition beta uniforme au secteur. Cette cartographie guide le calibrage d'allocation sous-sectorielle : Surpondérer les segments avec score ≥ 60 et momentum positif, Sous-pondérer les segments avec marges compressees ou croissance negative, et conserver une exposition neutre aux segments en transition.</a:t>
+            </a:r>
+          </a:p>
+        </p:txBody>
+      </p:sp>
+      <p:sp>
+        <p:nvSpPr>
+          <p:cNvPr id="21" name="Rectangle 20"/>
           <p:cNvSpPr/>
           <p:nvPr/>
         </p:nvSpPr>
         <p:spPr>
           <a:xfrm>
-            <a:off x="3204000" y="1666800"/>
-            <a:ext cx="2700000" cy="162000"/>
+            <a:off x="0" y="4950000"/>
+            <a:ext cx="9144000" cy="180000"/>
           </a:xfrm>
           <a:prstGeom prst="rect">
             <a:avLst/>
@@ -33939,317 +34246,7 @@
       </p:sp>
       <p:sp>
         <p:nvSpPr>
-          <p:cNvPr id="21" name="Rectangle 20"/>
-          <p:cNvSpPr/>
-          <p:nvPr/>
-        </p:nvSpPr>
-        <p:spPr>
-          <a:xfrm>
-            <a:off x="3204000" y="1666800"/>
-            <a:ext cx="43200" cy="162000"/>
-          </a:xfrm>
-          <a:prstGeom prst="rect">
-            <a:avLst/>
-          </a:prstGeom>
-          <a:solidFill>
-            <a:srgbClr val="2A5298"/>
-          </a:solidFill>
-          <a:ln>
-            <a:noFill/>
-          </a:ln>
-        </p:spPr>
-        <p:style>
-          <a:lnRef idx="1">
-            <a:schemeClr val="accent1"/>
-          </a:lnRef>
-          <a:fillRef idx="3">
-            <a:schemeClr val="accent1"/>
-          </a:fillRef>
-          <a:effectRef idx="2">
-            <a:schemeClr val="accent1"/>
-          </a:effectRef>
-          <a:fontRef idx="minor">
-            <a:schemeClr val="lt1"/>
-          </a:fontRef>
-        </p:style>
-        <p:txBody>
-          <a:bodyPr rtlCol="0" anchor="ctr"/>
-          <a:lstStyle/>
-          <a:p>
-            <a:pPr algn="ctr"/>
-          </a:p>
-        </p:txBody>
-      </p:sp>
-      <p:sp>
-        <p:nvSpPr>
           <p:cNvPr id="22" name="TextBox 21"/>
-          <p:cNvSpPr txBox="1"/>
-          <p:nvPr/>
-        </p:nvSpPr>
-        <p:spPr>
-          <a:xfrm>
-            <a:off x="3294000" y="1684800"/>
-            <a:ext cx="2520000" cy="136800"/>
-          </a:xfrm>
-          <a:prstGeom prst="rect">
-            <a:avLst/>
-          </a:prstGeom>
-          <a:noFill/>
-        </p:spPr>
-        <p:txBody>
-          <a:bodyPr wrap="square">
-            <a:spAutoFit/>
-          </a:bodyPr>
-          <a:lstStyle/>
-          <a:p>
-            <a:pPr algn="l"/>
-            <a:r>
-              <a:rPr sz="800" b="1" i="0">
-                <a:solidFill>
-                  <a:srgbClr val="1B3A6B"/>
-                </a:solidFill>
-              </a:rPr>
-              <a:t>Banks - Diversified — Surpondérer</a:t>
-            </a:r>
-          </a:p>
-        </p:txBody>
-      </p:sp>
-      <p:sp>
-        <p:nvSpPr>
-          <p:cNvPr id="23" name="TextBox 22"/>
-          <p:cNvSpPr txBox="1"/>
-          <p:nvPr/>
-        </p:nvSpPr>
-        <p:spPr>
-          <a:xfrm>
-            <a:off x="3294000" y="1846800"/>
-            <a:ext cx="2520000" cy="900000"/>
-          </a:xfrm>
-          <a:prstGeom prst="rect">
-            <a:avLst/>
-          </a:prstGeom>
-          <a:noFill/>
-        </p:spPr>
-        <p:txBody>
-          <a:bodyPr wrap="square">
-            <a:spAutoFit/>
-          </a:bodyPr>
-          <a:lstStyle/>
-          <a:p>
-            <a:pPr algn="l"/>
-            <a:r>
-              <a:rPr sz="750" b="0" i="0">
-                <a:solidFill>
-                  <a:srgbClr val="555555"/>
-                </a:solidFill>
-              </a:rPr>
-              <a:t>• C (82/100)
-• BAC (81/100)
-• WFC (77/100)</a:t>
-            </a:r>
-          </a:p>
-        </p:txBody>
-      </p:sp>
-      <p:sp>
-        <p:nvSpPr>
-          <p:cNvPr id="24" name="Rectangle 23"/>
-          <p:cNvSpPr/>
-          <p:nvPr/>
-        </p:nvSpPr>
-        <p:spPr>
-          <a:xfrm>
-            <a:off x="6083999" y="1666800"/>
-            <a:ext cx="2700000" cy="162000"/>
-          </a:xfrm>
-          <a:prstGeom prst="rect">
-            <a:avLst/>
-          </a:prstGeom>
-          <a:solidFill>
-            <a:srgbClr val="F5F7FA"/>
-          </a:solidFill>
-          <a:ln>
-            <a:noFill/>
-          </a:ln>
-        </p:spPr>
-        <p:style>
-          <a:lnRef idx="1">
-            <a:schemeClr val="accent1"/>
-          </a:lnRef>
-          <a:fillRef idx="3">
-            <a:schemeClr val="accent1"/>
-          </a:fillRef>
-          <a:effectRef idx="2">
-            <a:schemeClr val="accent1"/>
-          </a:effectRef>
-          <a:fontRef idx="minor">
-            <a:schemeClr val="lt1"/>
-          </a:fontRef>
-        </p:style>
-        <p:txBody>
-          <a:bodyPr rtlCol="0" anchor="ctr"/>
-          <a:lstStyle/>
-          <a:p>
-            <a:pPr algn="ctr"/>
-          </a:p>
-        </p:txBody>
-      </p:sp>
-      <p:sp>
-        <p:nvSpPr>
-          <p:cNvPr id="25" name="Rectangle 24"/>
-          <p:cNvSpPr/>
-          <p:nvPr/>
-        </p:nvSpPr>
-        <p:spPr>
-          <a:xfrm>
-            <a:off x="6083999" y="1666800"/>
-            <a:ext cx="43200" cy="162000"/>
-          </a:xfrm>
-          <a:prstGeom prst="rect">
-            <a:avLst/>
-          </a:prstGeom>
-          <a:solidFill>
-            <a:srgbClr val="2A5298"/>
-          </a:solidFill>
-          <a:ln>
-            <a:noFill/>
-          </a:ln>
-        </p:spPr>
-        <p:style>
-          <a:lnRef idx="1">
-            <a:schemeClr val="accent1"/>
-          </a:lnRef>
-          <a:fillRef idx="3">
-            <a:schemeClr val="accent1"/>
-          </a:fillRef>
-          <a:effectRef idx="2">
-            <a:schemeClr val="accent1"/>
-          </a:effectRef>
-          <a:fontRef idx="minor">
-            <a:schemeClr val="lt1"/>
-          </a:fontRef>
-        </p:style>
-        <p:txBody>
-          <a:bodyPr rtlCol="0" anchor="ctr"/>
-          <a:lstStyle/>
-          <a:p>
-            <a:pPr algn="ctr"/>
-          </a:p>
-        </p:txBody>
-      </p:sp>
-      <p:sp>
-        <p:nvSpPr>
-          <p:cNvPr id="26" name="TextBox 25"/>
-          <p:cNvSpPr txBox="1"/>
-          <p:nvPr/>
-        </p:nvSpPr>
-        <p:spPr>
-          <a:xfrm>
-            <a:off x="6173999" y="1684800"/>
-            <a:ext cx="2520000" cy="136800"/>
-          </a:xfrm>
-          <a:prstGeom prst="rect">
-            <a:avLst/>
-          </a:prstGeom>
-          <a:noFill/>
-        </p:spPr>
-        <p:txBody>
-          <a:bodyPr wrap="square">
-            <a:spAutoFit/>
-          </a:bodyPr>
-          <a:lstStyle/>
-          <a:p>
-            <a:pPr algn="l"/>
-            <a:r>
-              <a:rPr sz="800" b="1" i="0">
-                <a:solidFill>
-                  <a:srgbClr val="1B3A6B"/>
-                </a:solidFill>
-              </a:rPr>
-              <a:t>Credit Services — Surpondérer</a:t>
-            </a:r>
-          </a:p>
-        </p:txBody>
-      </p:sp>
-      <p:sp>
-        <p:nvSpPr>
-          <p:cNvPr id="27" name="TextBox 26"/>
-          <p:cNvSpPr txBox="1"/>
-          <p:nvPr/>
-        </p:nvSpPr>
-        <p:spPr>
-          <a:xfrm>
-            <a:off x="6173999" y="1846800"/>
-            <a:ext cx="2520000" cy="900000"/>
-          </a:xfrm>
-          <a:prstGeom prst="rect">
-            <a:avLst/>
-          </a:prstGeom>
-          <a:noFill/>
-        </p:spPr>
-        <p:txBody>
-          <a:bodyPr wrap="square">
-            <a:spAutoFit/>
-          </a:bodyPr>
-          <a:lstStyle/>
-          <a:p>
-            <a:pPr algn="l"/>
-            <a:r>
-              <a:rPr sz="750" b="0" i="0">
-                <a:solidFill>
-                  <a:srgbClr val="555555"/>
-                </a:solidFill>
-              </a:rPr>
-              <a:t>• AXP (76/100)</a:t>
-            </a:r>
-          </a:p>
-        </p:txBody>
-      </p:sp>
-      <p:sp>
-        <p:nvSpPr>
-          <p:cNvPr id="28" name="Rectangle 27"/>
-          <p:cNvSpPr/>
-          <p:nvPr/>
-        </p:nvSpPr>
-        <p:spPr>
-          <a:xfrm>
-            <a:off x="0" y="4950000"/>
-            <a:ext cx="9144000" cy="180000"/>
-          </a:xfrm>
-          <a:prstGeom prst="rect">
-            <a:avLst/>
-          </a:prstGeom>
-          <a:solidFill>
-            <a:srgbClr val="F5F7FA"/>
-          </a:solidFill>
-          <a:ln>
-            <a:noFill/>
-          </a:ln>
-        </p:spPr>
-        <p:style>
-          <a:lnRef idx="1">
-            <a:schemeClr val="accent1"/>
-          </a:lnRef>
-          <a:fillRef idx="3">
-            <a:schemeClr val="accent1"/>
-          </a:fillRef>
-          <a:effectRef idx="2">
-            <a:schemeClr val="accent1"/>
-          </a:effectRef>
-          <a:fontRef idx="minor">
-            <a:schemeClr val="lt1"/>
-          </a:fontRef>
-        </p:style>
-        <p:txBody>
-          <a:bodyPr rtlCol="0" anchor="ctr"/>
-          <a:lstStyle/>
-          <a:p>
-            <a:pPr algn="ctr"/>
-          </a:p>
-        </p:txBody>
-      </p:sp>
-      <p:sp>
-        <p:nvSpPr>
-          <p:cNvPr id="29" name="TextBox 28"/>
           <p:cNvSpPr txBox="1"/>
           <p:nvPr/>
         </p:nvSpPr>

</xml_diff>